<commit_message>
Update candidate details (name, college email, college)
</commit_message>
<xml_diff>
--- a/docs/presentation.pptx
+++ b/docs/presentation.pptx
@@ -113,37 +113,37 @@
   <p:extLst>
     <p:ext uri="{521415D9-36F7-43E2-AB2F-B90AF26B5E84}">
       <p14:sectionLst xmlns:p14="http://schemas.microsoft.com/office/powerpoint/2010/main">
-        <p14:section name="Title" id="{9d7141b5-e820-183a-5ba5-d0fc7fa32a72}">
+        <p14:section name="Title" id="{4dd2b060-7f66-285a-1475-39d82ca9f10d}">
           <p14:sldIdLst>
             <p14:sldId id="256"/>
           </p14:sldIdLst>
         </p14:section>
-        <p14:section name="Problem &amp; Approach" id="{ff008d39-2e36-56df-5b82-6c02277fe6fa}">
+        <p14:section name="Problem &amp; Approach" id="{95424ce4-774b-6542-725b-cf19ef654d4f}">
           <p14:sldIdLst>
             <p14:sldId id="257"/>
           </p14:sldIdLst>
         </p14:section>
-        <p14:section name="System Design" id="{1540766b-4588-15eb-ffc5-1936936ebd59}">
+        <p14:section name="System Design" id="{7d49ea87-27a5-28cc-10f0-30ef8faf09ff}">
           <p14:sldIdLst>
             <p14:sldId id="258"/>
           </p14:sldIdLst>
         </p14:section>
-        <p14:section name="Implementation" id="{fa0f42b6-79d5-9632-c36e-f939016c3bab}">
+        <p14:section name="Implementation" id="{a5fd462e-8763-2841-6de3-6c1f319a8745}">
           <p14:sldIdLst>
             <p14:sldId id="259"/>
           </p14:sldIdLst>
         </p14:section>
-        <p14:section name="Results" id="{5f81502d-1688-d304-2e95-a5846d8f648b}">
+        <p14:section name="Results" id="{0173c4f7-c702-ccd6-f65d-8144c566106d}">
           <p14:sldIdLst>
             <p14:sldId id="260"/>
           </p14:sldIdLst>
         </p14:section>
-        <p14:section name="Domain Impact" id="{6ff1f395-40f7-069d-db7d-a6aa63f6866a}">
+        <p14:section name="Domain Impact" id="{17547e00-0122-3e3b-07d4-290eccbde7e4}">
           <p14:sldIdLst>
             <p14:sldId id="261"/>
           </p14:sldIdLst>
         </p14:section>
-        <p14:section name="Next Steps" id="{c0610642-6d2c-74ef-ac09-35dda9bb9cc2}">
+        <p14:section name="Next Steps" id="{85d9eeb2-8a53-702f-38fa-7bcc10010772}">
           <p14:sldIdLst>
             <p14:sldId id="262"/>
           </p14:sldIdLst>
@@ -2702,7 +2702,7 @@
                   <a:schemeClr val="accent1"/>
                 </a:solidFill>
               </a:rPr>
-              <a:t>Sreedaya G S  ·  Kerala Agricultural University</a:t>
+              <a:t>Goureesankar S Nair  ·  Vellore Institute of Technology (VIT)</a:t>
             </a:r>
             <a:endParaRPr lang="en-US" sz="1800" dirty="0"/>
           </a:p>

</xml_diff>

<commit_message>
Align with submission guidelines: README template formatting, data sources README, results-slide screenshot, AI usage disclosure; stop committing model binary
</commit_message>
<xml_diff>
--- a/docs/presentation.pptx
+++ b/docs/presentation.pptx
@@ -113,37 +113,37 @@
   <p:extLst>
     <p:ext uri="{521415D9-36F7-43E2-AB2F-B90AF26B5E84}">
       <p14:sectionLst xmlns:p14="http://schemas.microsoft.com/office/powerpoint/2010/main">
-        <p14:section name="Title" id="{4dd2b060-7f66-285a-1475-39d82ca9f10d}">
+        <p14:section name="Title" id="{2804f728-606e-c901-55b6-97f2795eaba0}">
           <p14:sldIdLst>
             <p14:sldId id="256"/>
           </p14:sldIdLst>
         </p14:section>
-        <p14:section name="Problem &amp; Approach" id="{95424ce4-774b-6542-725b-cf19ef654d4f}">
+        <p14:section name="Problem &amp; Approach" id="{7d4db8d9-64f8-db27-670b-7ff1e1eb584f}">
           <p14:sldIdLst>
             <p14:sldId id="257"/>
           </p14:sldIdLst>
         </p14:section>
-        <p14:section name="System Design" id="{7d49ea87-27a5-28cc-10f0-30ef8faf09ff}">
+        <p14:section name="System Design" id="{a359586b-1cc7-c496-5419-a8548408b56c}">
           <p14:sldIdLst>
             <p14:sldId id="258"/>
           </p14:sldIdLst>
         </p14:section>
-        <p14:section name="Implementation" id="{a5fd462e-8763-2841-6de3-6c1f319a8745}">
+        <p14:section name="Implementation" id="{7818a6f8-8aac-b72c-e9f7-82fce69b7cb2}">
           <p14:sldIdLst>
             <p14:sldId id="259"/>
           </p14:sldIdLst>
         </p14:section>
-        <p14:section name="Results" id="{0173c4f7-c702-ccd6-f65d-8144c566106d}">
+        <p14:section name="Results" id="{223e4477-7168-9eaf-48d4-00a0f8148b67}">
           <p14:sldIdLst>
             <p14:sldId id="260"/>
           </p14:sldIdLst>
         </p14:section>
-        <p14:section name="Domain Impact" id="{17547e00-0122-3e3b-07d4-290eccbde7e4}">
+        <p14:section name="Domain Impact" id="{c8ed1115-0c64-d1f7-04df-3e5022ac9d8a}">
           <p14:sldIdLst>
             <p14:sldId id="261"/>
           </p14:sldIdLst>
         </p14:section>
-        <p14:section name="Next Steps" id="{85d9eeb2-8a53-702f-38fa-7bcc10010772}">
+        <p14:section name="Next Steps" id="{6a85611c-4856-38da-aafc-9d681601c57e}">
           <p14:sldIdLst>
             <p14:sldId id="262"/>
           </p14:sldIdLst>
@@ -1607,7 +1607,7 @@
           <a:p>
             <a:r>
               <a:rPr lang="en-US" dirty="0"/>
-              <a:t>On a held-out set written after tuning, the offline engine beats general-purpose VADER on sentiment and a majority-class baseline on events by a wide margin. Dev-set numbers are much higher; I report the held-out ones because that's the honest generalisation estimate. The pipeline processes about 90 documents per second on a small CPU. Five stress tests fired automatically, one per real event cluster. Module A beat its naive variant; its returns are on synthetic prices and are illustrative.</a:t>
+              <a:t>On a held-out set written after tuning, the offline engine beats general-purpose VADER on sentiment and a majority-class baseline on events by a wide margin. Dev-set numbers are much higher; I report the held-out ones because that's the honest generalisation estimate. The pipeline processes about 90 documents per second on a small CPU. Five stress tests fired automatically, one per real event cluster. Module A beat its naive variant; its returns are on synthetic prices and are illustrative. The screenshot is the dashboard's Module B view of an automatically triggered stress test.</a:t>
             </a:r>
             <a:endParaRPr lang="en-US" dirty="0"/>
           </a:p>
@@ -6496,7 +6496,7 @@
         </p:nvGraphicFramePr>
         <p:xfrm>
           <a:off x="548640" y="1325880"/>
-          <a:ext cx="5760720" cy="4206240"/>
+          <a:ext cx="5029200" cy="4160520"/>
         </p:xfrm>
         <a:graphic xmlns:a="http://schemas.openxmlformats.org/drawingml/2006/main">
           <a:graphicData uri="http://schemas.openxmlformats.org/drawingml/2006/chart">
@@ -6512,8 +6512,8 @@
         </p:nvSpPr>
         <p:spPr>
           <a:xfrm>
-            <a:off x="548640" y="5623560"/>
-            <a:ext cx="5760720" cy="548640"/>
+            <a:off x="548640" y="5577840"/>
+            <a:ext cx="5029200" cy="594360"/>
           </a:xfrm>
           <a:prstGeom prst="rect">
             <a:avLst/>
@@ -6540,20 +6540,66 @@
           </a:p>
         </p:txBody>
       </p:sp>
-      <p:sp>
-        <p:nvSpPr>
-          <p:cNvPr id="5" name="card"/>
+      <p:pic>
+        <p:nvPicPr>
+          <p:cNvPr id="5" name="dashboard screenshot" descr="Dashboard: auto-triggered stress test showing portfolio value before and after, CET1 ratio and P&amp;L by product">    </p:cNvPr>
+          <p:cNvPicPr>
+            <a:picLocks noChangeAspect="1"/>
+          </p:cNvPicPr>
+          <p:nvPr/>
+        </p:nvPicPr>
+        <p:blipFill>
+          <a:blip r:embed="rId2"/>
+          <a:stretch>
+            <a:fillRect/>
+          </a:stretch>
+        </p:blipFill>
+        <p:spPr>
+          <a:xfrm>
+            <a:off x="5897880" y="1325880"/>
+            <a:ext cx="5715000" cy="3386667"/>
+          </a:xfrm>
+          <a:prstGeom prst="rect">
+            <a:avLst/>
+          </a:prstGeom>
+        </p:spPr>
+      </p:pic>
+      <p:sp>
+        <p:nvSpPr>
+          <p:cNvPr id="6" name="screenshot frame"/>
           <p:cNvSpPr/>
           <p:nvPr/>
         </p:nvSpPr>
         <p:spPr>
           <a:xfrm>
-            <a:off x="6720840" y="1371600"/>
-            <a:ext cx="4892040" cy="1298448"/>
+            <a:off x="5897880" y="1325880"/>
+            <a:ext cx="5715000" cy="3386667"/>
+          </a:xfrm>
+          <a:prstGeom prst="rect">
+            <a:avLst/>
+          </a:prstGeom>
+          <a:ln w="9525">
+            <a:solidFill>
+              <a:srgbClr val="8FA3BF"/>
+            </a:solidFill>
+            <a:prstDash val="solid"/>
+          </a:ln>
+        </p:spPr>
+      </p:sp>
+      <p:sp>
+        <p:nvSpPr>
+          <p:cNvPr id="7" name="card"/>
+          <p:cNvSpPr/>
+          <p:nvPr/>
+        </p:nvSpPr>
+        <p:spPr>
+          <a:xfrm>
+            <a:off x="5897880" y="4937760"/>
+            <a:ext cx="1828800" cy="1188720"/>
           </a:xfrm>
           <a:prstGeom prst="roundRect">
             <a:avLst>
-              <a:gd name="adj" fmla="val 5634"/>
+              <a:gd name="adj" fmla="val 6154"/>
             </a:avLst>
           </a:prstGeom>
           <a:solidFill>
@@ -6564,14 +6610,14 @@
       </p:sp>
       <p:sp>
         <p:nvSpPr>
-          <p:cNvPr id="6" name="Text 3"/>
+          <p:cNvPr id="8" name="Text 4"/>
           <p:cNvSpPr txBox="1"/>
           <p:nvPr/>
         </p:nvSpPr>
         <p:spPr>
           <a:xfrm>
-            <a:off x="6949440" y="1481328"/>
-            <a:ext cx="2103120" cy="1051560"/>
+            <a:off x="6035040" y="5029200"/>
+            <a:ext cx="1600200" cy="502920"/>
           </a:xfrm>
           <a:prstGeom prst="rect">
             <a:avLst/>
@@ -6587,7 +6633,7 @@
               <a:buNone/>
             </a:pPr>
             <a:r>
-              <a:rPr lang="en-US" sz="3600" b="1" dirty="0">
+              <a:rPr lang="en-US" sz="2000" b="1" dirty="0">
                 <a:solidFill>
                   <a:schemeClr val="accent2"/>
                 </a:solidFill>
@@ -6595,79 +6641,43 @@
                 <a:ea typeface="Cambria" pitchFamily="34" charset="-122"/>
                 <a:cs typeface="Cambria" pitchFamily="34" charset="-120"/>
               </a:rPr>
-              <a:t>641</a:t>
-            </a:r>
-            <a:endParaRPr lang="en-US" sz="3600" dirty="0"/>
-          </a:p>
-        </p:txBody>
-      </p:sp>
-      <p:sp>
-        <p:nvSpPr>
-          <p:cNvPr id="7" name="Text 4"/>
+              <a:t>641 signals</a:t>
+            </a:r>
+            <a:endParaRPr lang="en-US" sz="2000" dirty="0"/>
+          </a:p>
+        </p:txBody>
+      </p:sp>
+      <p:sp>
+        <p:nvSpPr>
+          <p:cNvPr id="9" name="Text 5"/>
           <p:cNvSpPr txBox="1"/>
           <p:nvPr/>
         </p:nvSpPr>
         <p:spPr>
           <a:xfrm>
-            <a:off x="9098280" y="1554480"/>
-            <a:ext cx="2377440" cy="457200"/>
-          </a:xfrm>
-          <a:prstGeom prst="rect">
-            <a:avLst/>
-          </a:prstGeom>
-          <a:noFill/>
-          <a:ln/>
-        </p:spPr>
-        <p:txBody>
-          <a:bodyPr wrap="square" lIns="0" tIns="0" rIns="0" bIns="0" rtlCol="0" anchor="ctr"/>
+            <a:off x="6035040" y="5532120"/>
+            <a:ext cx="1600200" cy="502920"/>
+          </a:xfrm>
+          <a:prstGeom prst="rect">
+            <a:avLst/>
+          </a:prstGeom>
+          <a:noFill/>
+          <a:ln/>
+        </p:spPr>
+        <p:txBody>
+          <a:bodyPr wrap="square" lIns="0" tIns="0" rIns="0" bIns="0" rtlCol="0" anchor="t"/>
           <a:lstStyle/>
           <a:p>
             <a:pPr indent="0" marL="0">
               <a:buNone/>
             </a:pPr>
             <a:r>
-              <a:rPr lang="en-US" sz="1500" b="1" dirty="0">
+              <a:rPr lang="en-US" sz="1200" dirty="0">
                 <a:solidFill>
                   <a:schemeClr val="tx1"/>
                 </a:solidFill>
               </a:rPr>
-              <a:t>signals from 625 docs</a:t>
-            </a:r>
-            <a:endParaRPr lang="en-US" sz="1500" dirty="0"/>
-          </a:p>
-        </p:txBody>
-      </p:sp>
-      <p:sp>
-        <p:nvSpPr>
-          <p:cNvPr id="8" name="Text 5"/>
-          <p:cNvSpPr txBox="1"/>
-          <p:nvPr/>
-        </p:nvSpPr>
-        <p:spPr>
-          <a:xfrm>
-            <a:off x="9098280" y="2011680"/>
-            <a:ext cx="2377440" cy="548640"/>
-          </a:xfrm>
-          <a:prstGeom prst="rect">
-            <a:avLst/>
-          </a:prstGeom>
-          <a:noFill/>
-          <a:ln/>
-        </p:spPr>
-        <p:txBody>
-          <a:bodyPr wrap="square" lIns="0" tIns="0" rIns="0" bIns="0" rtlCol="0" anchor="t"/>
-          <a:lstStyle/>
-          <a:p>
-            <a:pPr indent="0" marL="0">
-              <a:buNone/>
-            </a:pPr>
-            <a:r>
-              <a:rPr lang="en-US" sz="1200" dirty="0">
-                <a:solidFill>
-                  <a:schemeClr val="accent5"/>
-                </a:solidFill>
-              </a:rPr>
-              <a:t>~90 docs/s offline on 2 vCPU</a:t>
+              <a:t>from 625 docs, ~90 docs/s</a:t>
             </a:r>
             <a:endParaRPr lang="en-US" sz="1200" dirty="0"/>
           </a:p>
@@ -6675,18 +6685,18 @@
       </p:sp>
       <p:sp>
         <p:nvSpPr>
-          <p:cNvPr id="9" name="card"/>
+          <p:cNvPr id="10" name="card"/>
           <p:cNvSpPr/>
           <p:nvPr/>
         </p:nvSpPr>
         <p:spPr>
           <a:xfrm>
-            <a:off x="6720840" y="2852928"/>
-            <a:ext cx="4892040" cy="1298448"/>
+            <a:off x="7840980" y="4937760"/>
+            <a:ext cx="1828800" cy="1188720"/>
           </a:xfrm>
           <a:prstGeom prst="roundRect">
             <a:avLst>
-              <a:gd name="adj" fmla="val 5634"/>
+              <a:gd name="adj" fmla="val 6154"/>
             </a:avLst>
           </a:prstGeom>
           <a:solidFill>
@@ -6697,14 +6707,14 @@
       </p:sp>
       <p:sp>
         <p:nvSpPr>
-          <p:cNvPr id="10" name="Text 7"/>
+          <p:cNvPr id="11" name="Text 7"/>
           <p:cNvSpPr txBox="1"/>
           <p:nvPr/>
         </p:nvSpPr>
         <p:spPr>
           <a:xfrm>
-            <a:off x="6949440" y="2962656"/>
-            <a:ext cx="2103120" cy="1051560"/>
+            <a:off x="7978140" y="5029200"/>
+            <a:ext cx="1600200" cy="502920"/>
           </a:xfrm>
           <a:prstGeom prst="rect">
             <a:avLst/>
@@ -6720,7 +6730,7 @@
               <a:buNone/>
             </a:pPr>
             <a:r>
-              <a:rPr lang="en-US" sz="3600" b="1" dirty="0">
+              <a:rPr lang="en-US" sz="2000" b="1" dirty="0">
                 <a:solidFill>
                   <a:schemeClr val="accent2"/>
                 </a:solidFill>
@@ -6728,79 +6738,43 @@
                 <a:ea typeface="Cambria" pitchFamily="34" charset="-122"/>
                 <a:cs typeface="Cambria" pitchFamily="34" charset="-120"/>
               </a:rPr>
-              <a:t>5</a:t>
-            </a:r>
-            <a:endParaRPr lang="en-US" sz="3600" dirty="0"/>
-          </a:p>
-        </p:txBody>
-      </p:sp>
-      <p:sp>
-        <p:nvSpPr>
-          <p:cNvPr id="11" name="Text 8"/>
+              <a:t>5 stress tests</a:t>
+            </a:r>
+            <a:endParaRPr lang="en-US" sz="2000" dirty="0"/>
+          </a:p>
+        </p:txBody>
+      </p:sp>
+      <p:sp>
+        <p:nvSpPr>
+          <p:cNvPr id="12" name="Text 8"/>
           <p:cNvSpPr txBox="1"/>
           <p:nvPr/>
         </p:nvSpPr>
         <p:spPr>
           <a:xfrm>
-            <a:off x="9098280" y="3035808"/>
-            <a:ext cx="2377440" cy="457200"/>
-          </a:xfrm>
-          <a:prstGeom prst="rect">
-            <a:avLst/>
-          </a:prstGeom>
-          <a:noFill/>
-          <a:ln/>
-        </p:spPr>
-        <p:txBody>
-          <a:bodyPr wrap="square" lIns="0" tIns="0" rIns="0" bIns="0" rtlCol="0" anchor="ctr"/>
+            <a:off x="7978140" y="5532120"/>
+            <a:ext cx="1600200" cy="502920"/>
+          </a:xfrm>
+          <a:prstGeom prst="rect">
+            <a:avLst/>
+          </a:prstGeom>
+          <a:noFill/>
+          <a:ln/>
+        </p:spPr>
+        <p:txBody>
+          <a:bodyPr wrap="square" lIns="0" tIns="0" rIns="0" bIns="0" rtlCol="0" anchor="t"/>
           <a:lstStyle/>
           <a:p>
             <a:pPr indent="0" marL="0">
               <a:buNone/>
             </a:pPr>
             <a:r>
-              <a:rPr lang="en-US" sz="1500" b="1" dirty="0">
+              <a:rPr lang="en-US" sz="1200" dirty="0">
                 <a:solidFill>
                   <a:schemeClr val="tx1"/>
                 </a:solidFill>
               </a:rPr>
-              <a:t>stress tests auto-triggered</a:t>
-            </a:r>
-            <a:endParaRPr lang="en-US" sz="1500" dirty="0"/>
-          </a:p>
-        </p:txBody>
-      </p:sp>
-      <p:sp>
-        <p:nvSpPr>
-          <p:cNvPr id="12" name="Text 9"/>
-          <p:cNvSpPr txBox="1"/>
-          <p:nvPr/>
-        </p:nvSpPr>
-        <p:spPr>
-          <a:xfrm>
-            <a:off x="9098280" y="3493008"/>
-            <a:ext cx="2377440" cy="548640"/>
-          </a:xfrm>
-          <a:prstGeom prst="rect">
-            <a:avLst/>
-          </a:prstGeom>
-          <a:noFill/>
-          <a:ln/>
-        </p:spPr>
-        <p:txBody>
-          <a:bodyPr wrap="square" lIns="0" tIns="0" rIns="0" bIns="0" rtlCol="0" anchor="t"/>
-          <a:lstStyle/>
-          <a:p>
-            <a:pPr indent="0" marL="0">
-              <a:buNone/>
-            </a:pPr>
-            <a:r>
-              <a:rPr lang="en-US" sz="1200" dirty="0">
-                <a:solidFill>
-                  <a:schemeClr val="accent5"/>
-                </a:solidFill>
-              </a:rPr>
-              <a:t>1 per event cluster; high-impact ceasefire news correctly ignored</a:t>
+              <a:t>auto-triggered; ceasefire ignored</a:t>
             </a:r>
             <a:endParaRPr lang="en-US" sz="1200" dirty="0"/>
           </a:p>
@@ -6814,12 +6788,12 @@
         </p:nvSpPr>
         <p:spPr>
           <a:xfrm>
-            <a:off x="6720840" y="4334256"/>
-            <a:ext cx="4892040" cy="1298448"/>
+            <a:off x="9784080" y="4937760"/>
+            <a:ext cx="1828800" cy="1188720"/>
           </a:xfrm>
           <a:prstGeom prst="roundRect">
             <a:avLst>
-              <a:gd name="adj" fmla="val 5634"/>
+              <a:gd name="adj" fmla="val 6154"/>
             </a:avLst>
           </a:prstGeom>
           <a:solidFill>
@@ -6830,14 +6804,14 @@
       </p:sp>
       <p:sp>
         <p:nvSpPr>
-          <p:cNvPr id="14" name="Text 11"/>
+          <p:cNvPr id="14" name="Text 10"/>
           <p:cNvSpPr txBox="1"/>
           <p:nvPr/>
         </p:nvSpPr>
         <p:spPr>
           <a:xfrm>
-            <a:off x="6949440" y="4443984"/>
-            <a:ext cx="2103120" cy="1051560"/>
+            <a:off x="9921240" y="5029200"/>
+            <a:ext cx="1600200" cy="502920"/>
           </a:xfrm>
           <a:prstGeom prst="rect">
             <a:avLst/>
@@ -6853,7 +6827,7 @@
               <a:buNone/>
             </a:pPr>
             <a:r>
-              <a:rPr lang="en-US" sz="3600" b="1" dirty="0">
+              <a:rPr lang="en-US" sz="2000" b="1" dirty="0">
                 <a:solidFill>
                   <a:schemeClr val="accent2"/>
                 </a:solidFill>
@@ -6863,77 +6837,41 @@
               </a:rPr>
               <a:t>+0.29 pts</a:t>
             </a:r>
-            <a:endParaRPr lang="en-US" sz="3600" dirty="0"/>
-          </a:p>
-        </p:txBody>
-      </p:sp>
-      <p:sp>
-        <p:nvSpPr>
-          <p:cNvPr id="15" name="Text 12"/>
+            <a:endParaRPr lang="en-US" sz="2000" dirty="0"/>
+          </a:p>
+        </p:txBody>
+      </p:sp>
+      <p:sp>
+        <p:nvSpPr>
+          <p:cNvPr id="15" name="Text 11"/>
           <p:cNvSpPr txBox="1"/>
           <p:nvPr/>
         </p:nvSpPr>
         <p:spPr>
           <a:xfrm>
-            <a:off x="9098280" y="4517136"/>
-            <a:ext cx="2377440" cy="457200"/>
-          </a:xfrm>
-          <a:prstGeom prst="rect">
-            <a:avLst/>
-          </a:prstGeom>
-          <a:noFill/>
-          <a:ln/>
-        </p:spPr>
-        <p:txBody>
-          <a:bodyPr wrap="square" lIns="0" tIns="0" rIns="0" bIns="0" rtlCol="0" anchor="ctr"/>
+            <a:off x="9921240" y="5532120"/>
+            <a:ext cx="1600200" cy="502920"/>
+          </a:xfrm>
+          <a:prstGeom prst="rect">
+            <a:avLst/>
+          </a:prstGeom>
+          <a:noFill/>
+          <a:ln/>
+        </p:spPr>
+        <p:txBody>
+          <a:bodyPr wrap="square" lIns="0" tIns="0" rIns="0" bIns="0" rtlCol="0" anchor="t"/>
           <a:lstStyle/>
           <a:p>
             <a:pPr indent="0" marL="0">
               <a:buNone/>
             </a:pPr>
             <a:r>
-              <a:rPr lang="en-US" sz="1500" b="1" dirty="0">
+              <a:rPr lang="en-US" sz="1200" dirty="0">
                 <a:solidFill>
                   <a:schemeClr val="tx1"/>
                 </a:solidFill>
               </a:rPr>
-              <a:t>Module A active return</a:t>
-            </a:r>
-            <a:endParaRPr lang="en-US" sz="1500" dirty="0"/>
-          </a:p>
-        </p:txBody>
-      </p:sp>
-      <p:sp>
-        <p:nvSpPr>
-          <p:cNvPr id="16" name="Text 13"/>
-          <p:cNvSpPr txBox="1"/>
-          <p:nvPr/>
-        </p:nvSpPr>
-        <p:spPr>
-          <a:xfrm>
-            <a:off x="9098280" y="4974336"/>
-            <a:ext cx="2377440" cy="548640"/>
-          </a:xfrm>
-          <a:prstGeom prst="rect">
-            <a:avLst/>
-          </a:prstGeom>
-          <a:noFill/>
-          <a:ln/>
-        </p:spPr>
-        <p:txBody>
-          <a:bodyPr wrap="square" lIns="0" tIns="0" rIns="0" bIns="0" rtlCol="0" anchor="t"/>
-          <a:lstStyle/>
-          <a:p>
-            <a:pPr indent="0" marL="0">
-              <a:buNone/>
-            </a:pPr>
-            <a:r>
-              <a:rPr lang="en-US" sz="1200" dirty="0">
-                <a:solidFill>
-                  <a:schemeClr val="accent5"/>
-                </a:solidFill>
-              </a:rPr>
-              <a:t>vs −0.37 pts naive (no decay/smoothing); synthetic prices</a:t>
+              <a:t>Module A vs −0.37 naive</a:t>
             </a:r>
             <a:endParaRPr lang="en-US" sz="1200" dirty="0"/>
           </a:p>

</xml_diff>